<commit_message>
Remove rotulos de nomes (Wessels:, Queiroz:, Relato:) dos slides de tarefas das Aulas 1-9 e do material de apoio
</commit_message>
<xml_diff>
--- a/Aula01_Introducao_a_Computacao_e_ao_Pensamento_Computacional/Aula01_Teoria.pptx
+++ b/Aula01_Introducao_a_Computacao_e_ao_Pensamento_Computacional/Aula01_Teoria.pptx
@@ -2674,6 +2674,10 @@
           </a:solidFill>
           <a:ln/>
         </p:spPr>
+        <p:txBody>
+          <a:bodyPr/>
+          <a:p/>
+        </p:txBody>
       </p:sp>
       <p:sp>
         <p:nvSpPr>
@@ -2694,6 +2698,10 @@
           </a:solidFill>
           <a:ln/>
         </p:spPr>
+        <p:txBody>
+          <a:bodyPr/>
+          <a:p/>
+        </p:txBody>
       </p:sp>
       <p:sp>
         <p:nvSpPr>
@@ -2753,6 +2761,10 @@
           </a:solidFill>
           <a:ln/>
         </p:spPr>
+        <p:txBody>
+          <a:bodyPr/>
+          <a:p/>
+        </p:txBody>
       </p:sp>
       <p:pic>
         <p:nvPicPr>
@@ -2883,6 +2895,10 @@
           </a:solidFill>
           <a:ln/>
         </p:spPr>
+        <p:txBody>
+          <a:bodyPr/>
+          <a:p/>
+        </p:txBody>
       </p:sp>
       <p:sp>
         <p:nvSpPr>
@@ -3052,6 +3068,10 @@
           </a:solidFill>
           <a:ln/>
         </p:spPr>
+        <p:txBody>
+          <a:bodyPr/>
+          <a:p/>
+        </p:txBody>
       </p:sp>
       <p:sp>
         <p:nvSpPr>
@@ -3072,6 +3092,10 @@
           </a:solidFill>
           <a:ln/>
         </p:spPr>
+        <p:txBody>
+          <a:bodyPr/>
+          <a:p/>
+        </p:txBody>
       </p:sp>
       <p:sp>
         <p:nvSpPr>
@@ -3131,6 +3155,10 @@
           </a:solidFill>
           <a:ln/>
         </p:spPr>
+        <p:txBody>
+          <a:bodyPr/>
+          <a:p/>
+        </p:txBody>
       </p:sp>
       <p:sp>
         <p:nvSpPr>
@@ -3273,6 +3301,10 @@
           </a:solidFill>
           <a:ln/>
         </p:spPr>
+        <p:txBody>
+          <a:bodyPr/>
+          <a:p/>
+        </p:txBody>
       </p:sp>
       <p:sp>
         <p:nvSpPr>
@@ -3565,6 +3597,10 @@
           </a:solidFill>
           <a:ln/>
         </p:spPr>
+        <p:txBody>
+          <a:bodyPr/>
+          <a:p/>
+        </p:txBody>
       </p:sp>
       <p:sp>
         <p:nvSpPr>
@@ -3675,6 +3711,10 @@
             </a:outerShdw>
           </a:effectLst>
         </p:spPr>
+        <p:txBody>
+          <a:bodyPr/>
+          <a:p/>
+        </p:txBody>
       </p:sp>
       <p:sp>
         <p:nvSpPr>
@@ -3876,6 +3916,10 @@
             </a:outerShdw>
           </a:effectLst>
         </p:spPr>
+        <p:txBody>
+          <a:bodyPr/>
+          <a:p/>
+        </p:txBody>
       </p:sp>
       <p:sp>
         <p:nvSpPr>
@@ -4157,6 +4201,10 @@
             </a:outerShdw>
           </a:effectLst>
         </p:spPr>
+        <p:txBody>
+          <a:bodyPr/>
+          <a:p/>
+        </p:txBody>
       </p:sp>
       <p:sp>
         <p:nvSpPr>
@@ -4261,7 +4309,7 @@
                 <a:ea typeface="Calibri" pitchFamily="34" charset="-122"/>
                 <a:cs typeface="Calibri" pitchFamily="34" charset="-120"/>
               </a:rPr>
-              <a:t>Relato: deslocar foco da ferramenta para a tarefa.</a:t>
+              <a:t>Deslocar foco da ferramenta para a tarefa.</a:t>
             </a:r>
             <a:endParaRPr lang="en-US" sz="1150" dirty="0"/>
           </a:p>
@@ -4285,7 +4333,7 @@
                 <a:ea typeface="Calibri" pitchFamily="34" charset="-122"/>
                 <a:cs typeface="Calibri" pitchFamily="34" charset="-120"/>
               </a:rPr>
-              <a:t>Wessels: organizar dados é componente crítico da representação.</a:t>
+              <a:t>Organizar dados é componente crítico da representação.</a:t>
             </a:r>
             <a:endParaRPr lang="en-US" sz="1150" dirty="0"/>
           </a:p>
@@ -4309,7 +4357,7 @@
                 <a:ea typeface="Calibri" pitchFamily="34" charset="-122"/>
                 <a:cs typeface="Calibri" pitchFamily="34" charset="-120"/>
               </a:rPr>
-              <a:t>Queiroz: o resultado final não esgota a aprendizagem do conceito.</a:t>
+              <a:t>O resultado final não esgota a aprendizagem do conceito.</a:t>
             </a:r>
             <a:endParaRPr lang="en-US" sz="1150" dirty="0"/>
           </a:p>
@@ -4343,6 +4391,10 @@
             </a:outerShdw>
           </a:effectLst>
         </p:spPr>
+        <p:txBody>
+          <a:bodyPr/>
+          <a:p/>
+        </p:txBody>
       </p:sp>
       <p:sp>
         <p:nvSpPr>
@@ -4596,6 +4648,10 @@
           </a:solidFill>
           <a:ln/>
         </p:spPr>
+        <p:txBody>
+          <a:bodyPr/>
+          <a:p/>
+        </p:txBody>
       </p:sp>
       <p:sp>
         <p:nvSpPr>
@@ -4706,6 +4762,10 @@
             </a:outerShdw>
           </a:effectLst>
         </p:spPr>
+        <p:txBody>
+          <a:bodyPr/>
+          <a:p/>
+        </p:txBody>
       </p:sp>
       <p:sp>
         <p:nvSpPr>
@@ -4907,6 +4967,10 @@
             </a:outerShdw>
           </a:effectLst>
         </p:spPr>
+        <p:txBody>
+          <a:bodyPr/>
+          <a:p/>
+        </p:txBody>
       </p:sp>
       <p:sp>
         <p:nvSpPr>
@@ -5290,6 +5354,10 @@
             </a:outerShdw>
           </a:effectLst>
         </p:spPr>
+        <p:txBody>
+          <a:bodyPr/>
+          <a:p/>
+        </p:txBody>
       </p:sp>
       <p:sp>
         <p:nvSpPr>
@@ -5394,7 +5462,7 @@
                 <a:ea typeface="Calibri" pitchFamily="34" charset="-122"/>
                 <a:cs typeface="Calibri" pitchFamily="34" charset="-120"/>
               </a:rPr>
-              <a:t>Relato: explicitar variáveis, relações e restrições.</a:t>
+              <a:t>Explicitar variáveis, relações e restrições.</a:t>
             </a:r>
             <a:endParaRPr lang="en-US" sz="1150" dirty="0"/>
           </a:p>
@@ -5418,7 +5486,7 @@
                 <a:ea typeface="Calibri" pitchFamily="34" charset="-122"/>
                 <a:cs typeface="Calibri" pitchFamily="34" charset="-120"/>
               </a:rPr>
-              <a:t>Queiroz: representações ampliam a percepção de propriedades e relações.</a:t>
+              <a:t>Representações ampliam a percepção de propriedades e relações.</a:t>
             </a:r>
             <a:endParaRPr lang="en-US" sz="1150" dirty="0"/>
           </a:p>
@@ -5442,7 +5510,7 @@
                 <a:ea typeface="Calibri" pitchFamily="34" charset="-122"/>
                 <a:cs typeface="Calibri" pitchFamily="34" charset="-120"/>
               </a:rPr>
-              <a:t>Wessels: o contexto e o tipo de dado influenciam a representação escolhida.</a:t>
+              <a:t>O contexto e o tipo de dado influenciam a representação escolhida.</a:t>
             </a:r>
             <a:endParaRPr lang="en-US" sz="1150" dirty="0"/>
           </a:p>
@@ -5476,6 +5544,10 @@
             </a:outerShdw>
           </a:effectLst>
         </p:spPr>
+        <p:txBody>
+          <a:bodyPr/>
+          <a:p/>
+        </p:txBody>
       </p:sp>
       <p:sp>
         <p:nvSpPr>
@@ -5729,6 +5801,10 @@
           </a:solidFill>
           <a:ln/>
         </p:spPr>
+        <p:txBody>
+          <a:bodyPr/>
+          <a:p/>
+        </p:txBody>
       </p:sp>
       <p:sp>
         <p:nvSpPr>
@@ -5839,6 +5915,10 @@
             </a:outerShdw>
           </a:effectLst>
         </p:spPr>
+        <p:txBody>
+          <a:bodyPr/>
+          <a:p/>
+        </p:txBody>
       </p:sp>
       <p:sp>
         <p:nvSpPr>
@@ -6040,6 +6120,10 @@
             </a:outerShdw>
           </a:effectLst>
         </p:spPr>
+        <p:txBody>
+          <a:bodyPr/>
+          <a:p/>
+        </p:txBody>
       </p:sp>
       <p:sp>
         <p:nvSpPr>
@@ -6508,6 +6592,10 @@
             </a:outerShdw>
           </a:effectLst>
         </p:spPr>
+        <p:txBody>
+          <a:bodyPr/>
+          <a:p/>
+        </p:txBody>
       </p:sp>
       <p:sp>
         <p:nvSpPr>
@@ -6612,7 +6700,7 @@
                 <a:ea typeface="Calibri" pitchFamily="34" charset="-122"/>
                 <a:cs typeface="Calibri" pitchFamily="34" charset="-120"/>
               </a:rPr>
-              <a:t>Wessels: organizar dados é componente crítico da representação.</a:t>
+              <a:t>Organizar dados é componente crítico da representação.</a:t>
             </a:r>
             <a:endParaRPr lang="en-US" sz="1150" dirty="0"/>
           </a:p>
@@ -6636,7 +6724,7 @@
                 <a:ea typeface="Calibri" pitchFamily="34" charset="-122"/>
                 <a:cs typeface="Calibri" pitchFamily="34" charset="-120"/>
               </a:rPr>
-              <a:t>Queiroz: múltiplas expressões exibem aspectos distintos do mesmo conceito.</a:t>
+              <a:t>Múltiplas expressões exibem aspectos distintos do mesmo conceito.</a:t>
             </a:r>
             <a:endParaRPr lang="en-US" sz="1150" dirty="0"/>
           </a:p>
@@ -6660,7 +6748,7 @@
                 <a:ea typeface="Calibri" pitchFamily="34" charset="-122"/>
                 <a:cs typeface="Calibri" pitchFamily="34" charset="-120"/>
               </a:rPr>
-              <a:t>Relato: articular código, texto, tabela, gráfico e interpretação.</a:t>
+              <a:t>Articular código, texto, tabela, gráfico e interpretação.</a:t>
             </a:r>
             <a:endParaRPr lang="en-US" sz="1150" dirty="0"/>
           </a:p>
@@ -6694,6 +6782,10 @@
             </a:outerShdw>
           </a:effectLst>
         </p:spPr>
+        <p:txBody>
+          <a:bodyPr/>
+          <a:p/>
+        </p:txBody>
       </p:sp>
       <p:sp>
         <p:nvSpPr>
@@ -6947,6 +7039,10 @@
           </a:solidFill>
           <a:ln/>
         </p:spPr>
+        <p:txBody>
+          <a:bodyPr/>
+          <a:p/>
+        </p:txBody>
       </p:sp>
       <p:sp>
         <p:nvSpPr>
@@ -7057,6 +7153,10 @@
             </a:outerShdw>
           </a:effectLst>
         </p:spPr>
+        <p:txBody>
+          <a:bodyPr/>
+          <a:p/>
+        </p:txBody>
       </p:sp>
       <p:sp>
         <p:nvSpPr>
@@ -7258,6 +7358,10 @@
             </a:outerShdw>
           </a:effectLst>
         </p:spPr>
+        <p:txBody>
+          <a:bodyPr/>
+          <a:p/>
+        </p:txBody>
       </p:sp>
       <p:sp>
         <p:nvSpPr>
@@ -7743,6 +7847,10 @@
             </a:outerShdw>
           </a:effectLst>
         </p:spPr>
+        <p:txBody>
+          <a:bodyPr/>
+          <a:p/>
+        </p:txBody>
       </p:sp>
       <p:sp>
         <p:nvSpPr>
@@ -7847,7 +7955,7 @@
                 <a:ea typeface="Calibri" pitchFamily="34" charset="-122"/>
                 <a:cs typeface="Calibri" pitchFamily="34" charset="-120"/>
               </a:rPr>
-              <a:t>Relato: permitir manipulação de parâmetros e comparação de estados.</a:t>
+              <a:t>Permitir manipulação de parâmetros e comparação de estados.</a:t>
             </a:r>
             <a:endParaRPr lang="en-US" sz="1150" dirty="0"/>
           </a:p>
@@ -7871,7 +7979,7 @@
                 <a:ea typeface="Calibri" pitchFamily="34" charset="-122"/>
                 <a:cs typeface="Calibri" pitchFamily="34" charset="-120"/>
               </a:rPr>
-              <a:t>Queiroz: a interação consciente com a forma favorece reflexão conceitual.</a:t>
+              <a:t>A interação consciente com a forma favorece reflexão conceitual.</a:t>
             </a:r>
             <a:endParaRPr lang="en-US" sz="1150" dirty="0"/>
           </a:p>
@@ -7895,7 +8003,7 @@
                 <a:ea typeface="Calibri" pitchFamily="34" charset="-122"/>
                 <a:cs typeface="Calibri" pitchFamily="34" charset="-120"/>
               </a:rPr>
-              <a:t>Wessels: múltiplas representações indicam modelagem mais bem-sucedida.</a:t>
+              <a:t>Múltiplas representações indicam modelagem mais bem-sucedida.</a:t>
             </a:r>
             <a:endParaRPr lang="en-US" sz="1150" dirty="0"/>
           </a:p>
@@ -7929,6 +8037,10 @@
             </a:outerShdw>
           </a:effectLst>
         </p:spPr>
+        <p:txBody>
+          <a:bodyPr/>
+          <a:p/>
+        </p:txBody>
       </p:sp>
       <p:sp>
         <p:nvSpPr>
@@ -8182,6 +8294,10 @@
           </a:solidFill>
           <a:ln/>
         </p:spPr>
+        <p:txBody>
+          <a:bodyPr/>
+          <a:p/>
+        </p:txBody>
       </p:sp>
       <p:sp>
         <p:nvSpPr>
@@ -8292,6 +8408,10 @@
             </a:outerShdw>
           </a:effectLst>
         </p:spPr>
+        <p:txBody>
+          <a:bodyPr/>
+          <a:p/>
+        </p:txBody>
       </p:sp>
       <p:sp>
         <p:nvSpPr>
@@ -8493,6 +8613,10 @@
             </a:outerShdw>
           </a:effectLst>
         </p:spPr>
+        <p:txBody>
+          <a:bodyPr/>
+          <a:p/>
+        </p:txBody>
       </p:sp>
       <p:sp>
         <p:nvSpPr>
@@ -8669,6 +8793,10 @@
             </a:outerShdw>
           </a:effectLst>
         </p:spPr>
+        <p:txBody>
+          <a:bodyPr/>
+          <a:p/>
+        </p:txBody>
       </p:sp>
       <p:sp>
         <p:nvSpPr>
@@ -8773,7 +8901,7 @@
                 <a:ea typeface="Calibri" pitchFamily="34" charset="-122"/>
                 <a:cs typeface="Calibri" pitchFamily="34" charset="-120"/>
               </a:rPr>
-              <a:t>Wessels: múltiplas representações indicam modelagem mais bem-sucedida.</a:t>
+              <a:t>Múltiplas representações indicam modelagem mais bem-sucedida.</a:t>
             </a:r>
             <a:endParaRPr lang="en-US" sz="1150" dirty="0"/>
           </a:p>
@@ -8797,7 +8925,7 @@
                 <a:ea typeface="Calibri" pitchFamily="34" charset="-122"/>
                 <a:cs typeface="Calibri" pitchFamily="34" charset="-120"/>
               </a:rPr>
-              <a:t>Queiroz: múltiplas expressões exibem aspectos distintos do mesmo conceito.</a:t>
+              <a:t>Múltiplas expressões exibem aspectos distintos do mesmo conceito.</a:t>
             </a:r>
             <a:endParaRPr lang="en-US" sz="1150" dirty="0"/>
           </a:p>
@@ -8821,7 +8949,7 @@
                 <a:ea typeface="Calibri" pitchFamily="34" charset="-122"/>
                 <a:cs typeface="Calibri" pitchFamily="34" charset="-120"/>
               </a:rPr>
-              <a:t>Relato: articular código, texto, tabela, gráfico e interpretação.</a:t>
+              <a:t>Articular código, texto, tabela, gráfico e interpretação.</a:t>
             </a:r>
             <a:endParaRPr lang="en-US" sz="1150" dirty="0"/>
           </a:p>
@@ -8855,6 +8983,10 @@
             </a:outerShdw>
           </a:effectLst>
         </p:spPr>
+        <p:txBody>
+          <a:bodyPr/>
+          <a:p/>
+        </p:txBody>
       </p:sp>
       <p:sp>
         <p:nvSpPr>
@@ -9108,6 +9240,10 @@
           </a:solidFill>
           <a:ln/>
         </p:spPr>
+        <p:txBody>
+          <a:bodyPr/>
+          <a:p/>
+        </p:txBody>
       </p:sp>
       <p:sp>
         <p:nvSpPr>
@@ -9218,6 +9354,10 @@
             </a:outerShdw>
           </a:effectLst>
         </p:spPr>
+        <p:txBody>
+          <a:bodyPr/>
+          <a:p/>
+        </p:txBody>
       </p:sp>
       <p:sp>
         <p:nvSpPr>
@@ -9419,6 +9559,10 @@
             </a:outerShdw>
           </a:effectLst>
         </p:spPr>
+        <p:txBody>
+          <a:bodyPr/>
+          <a:p/>
+        </p:txBody>
       </p:sp>
       <p:sp>
         <p:nvSpPr>
@@ -10091,6 +10235,10 @@
             </a:outerShdw>
           </a:effectLst>
         </p:spPr>
+        <p:txBody>
+          <a:bodyPr/>
+          <a:p/>
+        </p:txBody>
       </p:sp>
       <p:sp>
         <p:nvSpPr>
@@ -10195,7 +10343,7 @@
                 <a:ea typeface="Calibri" pitchFamily="34" charset="-122"/>
                 <a:cs typeface="Calibri" pitchFamily="34" charset="-120"/>
               </a:rPr>
-              <a:t>Wessels: transnumeração torna dados interpretáveis em nova forma.</a:t>
+              <a:t>Transnumeração torna dados interpretáveis em nova forma.</a:t>
             </a:r>
             <a:endParaRPr lang="en-US" sz="1150" dirty="0"/>
           </a:p>
@@ -10219,7 +10367,7 @@
                 <a:ea typeface="Calibri" pitchFamily="34" charset="-122"/>
                 <a:cs typeface="Calibri" pitchFamily="34" charset="-120"/>
               </a:rPr>
-              <a:t>Queiroz: representações ampliam a percepção de propriedades e relações.</a:t>
+              <a:t>Representações ampliam a percepção de propriedades e relações.</a:t>
             </a:r>
             <a:endParaRPr lang="en-US" sz="1150" dirty="0"/>
           </a:p>
@@ -10243,7 +10391,7 @@
                 <a:ea typeface="Calibri" pitchFamily="34" charset="-122"/>
                 <a:cs typeface="Calibri" pitchFamily="34" charset="-120"/>
               </a:rPr>
-              <a:t>Relato: solicitar explicação do raciocínio desenvolvido.</a:t>
+              <a:t>Solicitar explicação do raciocínio desenvolvido.</a:t>
             </a:r>
             <a:endParaRPr lang="en-US" sz="1150" dirty="0"/>
           </a:p>
@@ -10277,6 +10425,10 @@
             </a:outerShdw>
           </a:effectLst>
         </p:spPr>
+        <p:txBody>
+          <a:bodyPr/>
+          <a:p/>
+        </p:txBody>
       </p:sp>
       <p:sp>
         <p:nvSpPr>
@@ -10530,6 +10682,10 @@
           </a:solidFill>
           <a:ln/>
         </p:spPr>
+        <p:txBody>
+          <a:bodyPr/>
+          <a:p/>
+        </p:txBody>
       </p:sp>
       <p:sp>
         <p:nvSpPr>
@@ -10640,6 +10796,10 @@
             </a:outerShdw>
           </a:effectLst>
         </p:spPr>
+        <p:txBody>
+          <a:bodyPr/>
+          <a:p/>
+        </p:txBody>
       </p:sp>
       <p:sp>
         <p:nvSpPr>
@@ -10841,6 +11001,10 @@
             </a:outerShdw>
           </a:effectLst>
         </p:spPr>
+        <p:txBody>
+          <a:bodyPr/>
+          <a:p/>
+        </p:txBody>
       </p:sp>
       <p:sp>
         <p:nvSpPr>
@@ -11190,6 +11354,10 @@
             </a:outerShdw>
           </a:effectLst>
         </p:spPr>
+        <p:txBody>
+          <a:bodyPr/>
+          <a:p/>
+        </p:txBody>
       </p:sp>
       <p:sp>
         <p:nvSpPr>
@@ -11294,7 +11462,7 @@
                 <a:ea typeface="Calibri" pitchFamily="34" charset="-122"/>
                 <a:cs typeface="Calibri" pitchFamily="34" charset="-120"/>
               </a:rPr>
-              <a:t>Wessels: níveis SOLO ajudam a observar respostas de menor a maior integração.</a:t>
+              <a:t>Níveis SOLO ajudam a observar respostas de menor a maior integração.</a:t>
             </a:r>
             <a:endParaRPr lang="en-US" sz="1150" dirty="0"/>
           </a:p>
@@ -11318,7 +11486,7 @@
                 <a:ea typeface="Calibri" pitchFamily="34" charset="-122"/>
                 <a:cs typeface="Calibri" pitchFamily="34" charset="-120"/>
               </a:rPr>
-              <a:t>Queiroz: a análise qualitativa observa invariantes e relações mobilizadas na ação.</a:t>
+              <a:t>A análise qualitativa observa invariantes e relações mobilizadas na ação.</a:t>
             </a:r>
             <a:endParaRPr lang="en-US" sz="1150" dirty="0"/>
           </a:p>
@@ -11342,7 +11510,7 @@
                 <a:ea typeface="Calibri" pitchFamily="34" charset="-122"/>
                 <a:cs typeface="Calibri" pitchFamily="34" charset="-120"/>
               </a:rPr>
-              <a:t>Relato: avaliar o percurso de pensamento, não apenas o código final.</a:t>
+              <a:t>Avaliar o percurso de pensamento, não apenas o código final.</a:t>
             </a:r>
             <a:endParaRPr lang="en-US" sz="1150" dirty="0"/>
           </a:p>
@@ -11376,6 +11544,10 @@
             </a:outerShdw>
           </a:effectLst>
         </p:spPr>
+        <p:txBody>
+          <a:bodyPr/>
+          <a:p/>
+        </p:txBody>
       </p:sp>
       <p:sp>
         <p:nvSpPr>
@@ -11629,6 +11801,10 @@
           </a:solidFill>
           <a:ln/>
         </p:spPr>
+        <p:txBody>
+          <a:bodyPr/>
+          <a:p/>
+        </p:txBody>
       </p:sp>
       <p:sp>
         <p:nvSpPr>
@@ -11739,6 +11915,10 @@
             </a:outerShdw>
           </a:effectLst>
         </p:spPr>
+        <p:txBody>
+          <a:bodyPr/>
+          <a:p/>
+        </p:txBody>
       </p:sp>
       <p:sp>
         <p:nvSpPr>
@@ -11940,6 +12120,10 @@
             </a:outerShdw>
           </a:effectLst>
         </p:spPr>
+        <p:txBody>
+          <a:bodyPr/>
+          <a:p/>
+        </p:txBody>
       </p:sp>
       <p:sp>
         <p:nvSpPr>
@@ -12388,6 +12572,10 @@
             </a:outerShdw>
           </a:effectLst>
         </p:spPr>
+        <p:txBody>
+          <a:bodyPr/>
+          <a:p/>
+        </p:txBody>
       </p:sp>
       <p:sp>
         <p:nvSpPr>
@@ -12492,7 +12680,7 @@
                 <a:ea typeface="Calibri" pitchFamily="34" charset="-122"/>
                 <a:cs typeface="Calibri" pitchFamily="34" charset="-120"/>
               </a:rPr>
-              <a:t>Relato: solicitar explicação do raciocínio desenvolvido.</a:t>
+              <a:t>Solicitar explicação do raciocínio desenvolvido.</a:t>
             </a:r>
             <a:endParaRPr lang="en-US" sz="1150" dirty="0"/>
           </a:p>
@@ -12516,7 +12704,7 @@
                 <a:ea typeface="Calibri" pitchFamily="34" charset="-122"/>
                 <a:cs typeface="Calibri" pitchFamily="34" charset="-120"/>
               </a:rPr>
-              <a:t>Queiroz: feedback visual/textual deve orientar interpretação, não apenas corrigir.</a:t>
+              <a:t>Feedback visual/textual deve orientar interpretação, não apenas corrigir.</a:t>
             </a:r>
             <a:endParaRPr lang="en-US" sz="1150" dirty="0"/>
           </a:p>
@@ -12540,7 +12728,7 @@
                 <a:ea typeface="Calibri" pitchFamily="34" charset="-122"/>
                 <a:cs typeface="Calibri" pitchFamily="34" charset="-120"/>
               </a:rPr>
-              <a:t>Wessels: atividades planejadas desenvolvem representação e pensamento de ordem superior.</a:t>
+              <a:t>Atividades planejadas desenvolvem representação e pensamento de ordem superior.</a:t>
             </a:r>
             <a:endParaRPr lang="en-US" sz="1150" dirty="0"/>
           </a:p>
@@ -12574,6 +12762,10 @@
             </a:outerShdw>
           </a:effectLst>
         </p:spPr>
+        <p:txBody>
+          <a:bodyPr/>
+          <a:p/>
+        </p:txBody>
       </p:sp>
       <p:sp>
         <p:nvSpPr>
@@ -12827,6 +13019,10 @@
           </a:solidFill>
           <a:ln/>
         </p:spPr>
+        <p:txBody>
+          <a:bodyPr/>
+          <a:p/>
+        </p:txBody>
       </p:sp>
       <p:sp>
         <p:nvSpPr>
@@ -12937,6 +13133,10 @@
             </a:outerShdw>
           </a:effectLst>
         </p:spPr>
+        <p:txBody>
+          <a:bodyPr/>
+          <a:p/>
+        </p:txBody>
       </p:sp>
       <p:sp>
         <p:nvSpPr>
@@ -13138,6 +13338,10 @@
             </a:outerShdw>
           </a:effectLst>
         </p:spPr>
+        <p:txBody>
+          <a:bodyPr/>
+          <a:p/>
+        </p:txBody>
       </p:sp>
       <p:sp>
         <p:nvSpPr>
@@ -13433,6 +13637,10 @@
             </a:outerShdw>
           </a:effectLst>
         </p:spPr>
+        <p:txBody>
+          <a:bodyPr/>
+          <a:p/>
+        </p:txBody>
       </p:sp>
       <p:sp>
         <p:nvSpPr>
@@ -13537,7 +13745,7 @@
                 <a:ea typeface="Calibri" pitchFamily="34" charset="-122"/>
                 <a:cs typeface="Calibri" pitchFamily="34" charset="-120"/>
               </a:rPr>
-              <a:t>Queiroz: feedback visual/textual deve orientar interpretação, não apenas corrigir.</a:t>
+              <a:t>Feedback visual/textual deve orientar interpretação, não apenas corrigir.</a:t>
             </a:r>
             <a:endParaRPr lang="en-US" sz="1150" dirty="0"/>
           </a:p>
@@ -13561,7 +13769,7 @@
                 <a:ea typeface="Calibri" pitchFamily="34" charset="-122"/>
                 <a:cs typeface="Calibri" pitchFamily="34" charset="-120"/>
               </a:rPr>
-              <a:t>Relato: incluir revisão, depuração e reconstrução.</a:t>
+              <a:t>Incluir revisão, depuração e reconstrução.</a:t>
             </a:r>
             <a:endParaRPr lang="en-US" sz="1150" dirty="0"/>
           </a:p>
@@ -13585,7 +13793,7 @@
                 <a:ea typeface="Calibri" pitchFamily="34" charset="-122"/>
                 <a:cs typeface="Calibri" pitchFamily="34" charset="-120"/>
               </a:rPr>
-              <a:t>Wessels: respostas idiossincráticas também revelam modos de pensar.</a:t>
+              <a:t>Respostas idiossincráticas também revelam modos de pensar.</a:t>
             </a:r>
             <a:endParaRPr lang="en-US" sz="1150" dirty="0"/>
           </a:p>
@@ -13619,6 +13827,10 @@
             </a:outerShdw>
           </a:effectLst>
         </p:spPr>
+        <p:txBody>
+          <a:bodyPr/>
+          <a:p/>
+        </p:txBody>
       </p:sp>
       <p:sp>
         <p:nvSpPr>
@@ -13872,6 +14084,10 @@
           </a:solidFill>
           <a:ln/>
         </p:spPr>
+        <p:txBody>
+          <a:bodyPr/>
+          <a:p/>
+        </p:txBody>
       </p:sp>
       <p:pic>
         <p:nvPicPr>
@@ -14006,6 +14222,10 @@
             </a:outerShdw>
           </a:effectLst>
         </p:spPr>
+        <p:txBody>
+          <a:bodyPr/>
+          <a:p/>
+        </p:txBody>
       </p:sp>
       <p:sp>
         <p:nvSpPr>
@@ -14116,6 +14336,10 @@
             </a:outerShdw>
           </a:effectLst>
         </p:spPr>
+        <p:txBody>
+          <a:bodyPr/>
+          <a:p/>
+        </p:txBody>
       </p:sp>
       <p:sp>
         <p:nvSpPr>
@@ -14226,6 +14450,10 @@
             </a:outerShdw>
           </a:effectLst>
         </p:spPr>
+        <p:txBody>
+          <a:bodyPr/>
+          <a:p/>
+        </p:txBody>
       </p:sp>
       <p:sp>
         <p:nvSpPr>
@@ -14336,6 +14564,10 @@
             </a:outerShdw>
           </a:effectLst>
         </p:spPr>
+        <p:txBody>
+          <a:bodyPr/>
+          <a:p/>
+        </p:txBody>
       </p:sp>
       <p:sp>
         <p:nvSpPr>
@@ -14491,6 +14723,10 @@
           </a:solidFill>
           <a:ln/>
         </p:spPr>
+        <p:txBody>
+          <a:bodyPr/>
+          <a:p/>
+        </p:txBody>
       </p:sp>
       <p:sp>
         <p:nvSpPr>
@@ -14660,6 +14896,10 @@
           </a:solidFill>
           <a:ln/>
         </p:spPr>
+        <p:txBody>
+          <a:bodyPr/>
+          <a:p/>
+        </p:txBody>
       </p:sp>
       <p:sp>
         <p:nvSpPr>
@@ -14770,6 +15010,10 @@
             </a:outerShdw>
           </a:effectLst>
         </p:spPr>
+        <p:txBody>
+          <a:bodyPr/>
+          <a:p/>
+        </p:txBody>
       </p:sp>
       <p:sp>
         <p:nvSpPr>
@@ -14971,6 +15215,10 @@
             </a:outerShdw>
           </a:effectLst>
         </p:spPr>
+        <p:txBody>
+          <a:bodyPr/>
+          <a:p/>
+        </p:txBody>
       </p:sp>
       <p:sp>
         <p:nvSpPr>
@@ -15181,6 +15429,10 @@
             </a:outerShdw>
           </a:effectLst>
         </p:spPr>
+        <p:txBody>
+          <a:bodyPr/>
+          <a:p/>
+        </p:txBody>
       </p:sp>
       <p:sp>
         <p:nvSpPr>
@@ -15285,7 +15537,7 @@
                 <a:ea typeface="Calibri" pitchFamily="34" charset="-122"/>
                 <a:cs typeface="Calibri" pitchFamily="34" charset="-120"/>
               </a:rPr>
-              <a:t>Relato: avaliar o percurso de pensamento, não apenas o código final.</a:t>
+              <a:t>Avaliar o percurso de pensamento, não apenas o código final.</a:t>
             </a:r>
             <a:endParaRPr lang="en-US" sz="1150" dirty="0"/>
           </a:p>
@@ -15309,7 +15561,7 @@
                 <a:ea typeface="Calibri" pitchFamily="34" charset="-122"/>
                 <a:cs typeface="Calibri" pitchFamily="34" charset="-120"/>
               </a:rPr>
-              <a:t>Queiroz: o percurso da tarefa revela mudanças no discurso e na ação.</a:t>
+              <a:t>O percurso da tarefa revela mudanças no discurso e na ação.</a:t>
             </a:r>
             <a:endParaRPr lang="en-US" sz="1150" dirty="0"/>
           </a:p>
@@ -15333,7 +15585,7 @@
                 <a:ea typeface="Calibri" pitchFamily="34" charset="-122"/>
                 <a:cs typeface="Calibri" pitchFamily="34" charset="-120"/>
               </a:rPr>
-              <a:t>Wessels: atividades planejadas desenvolvem representação e pensamento de ordem superior.</a:t>
+              <a:t>Atividades planejadas desenvolvem representação e pensamento de ordem superior.</a:t>
             </a:r>
             <a:endParaRPr lang="en-US" sz="1150" dirty="0"/>
           </a:p>
@@ -15367,6 +15619,10 @@
             </a:outerShdw>
           </a:effectLst>
         </p:spPr>
+        <p:txBody>
+          <a:bodyPr/>
+          <a:p/>
+        </p:txBody>
       </p:sp>
       <p:sp>
         <p:nvSpPr>
@@ -15620,6 +15876,10 @@
           </a:solidFill>
           <a:ln/>
         </p:spPr>
+        <p:txBody>
+          <a:bodyPr/>
+          <a:p/>
+        </p:txBody>
       </p:sp>
       <p:sp>
         <p:nvSpPr>
@@ -15640,6 +15900,10 @@
           </a:solidFill>
           <a:ln/>
         </p:spPr>
+        <p:txBody>
+          <a:bodyPr/>
+          <a:p/>
+        </p:txBody>
       </p:sp>
       <p:sp>
         <p:nvSpPr>
@@ -15660,6 +15924,10 @@
           </a:solidFill>
           <a:ln/>
         </p:spPr>
+        <p:txBody>
+          <a:bodyPr/>
+          <a:p/>
+        </p:txBody>
       </p:sp>
       <p:pic>
         <p:nvPicPr>
@@ -15826,6 +16094,10 @@
           </a:solidFill>
           <a:ln/>
         </p:spPr>
+        <p:txBody>
+          <a:bodyPr/>
+          <a:p/>
+        </p:txBody>
       </p:sp>
       <p:sp>
         <p:nvSpPr>
@@ -15918,6 +16190,10 @@
           </a:solidFill>
           <a:ln/>
         </p:spPr>
+        <p:txBody>
+          <a:bodyPr/>
+          <a:p/>
+        </p:txBody>
       </p:sp>
       <p:sp>
         <p:nvSpPr>
@@ -16016,6 +16292,10 @@
           </a:solidFill>
           <a:ln/>
         </p:spPr>
+        <p:txBody>
+          <a:bodyPr/>
+          <a:p/>
+        </p:txBody>
       </p:sp>
       <p:pic>
         <p:nvPicPr>
@@ -16170,6 +16450,10 @@
           </a:solidFill>
           <a:ln/>
         </p:spPr>
+        <p:txBody>
+          <a:bodyPr/>
+          <a:p/>
+        </p:txBody>
       </p:sp>
       <p:pic>
         <p:nvPicPr>
@@ -16262,6 +16546,10 @@
             </a:outerShdw>
           </a:effectLst>
         </p:spPr>
+        <p:txBody>
+          <a:bodyPr/>
+          <a:p/>
+        </p:txBody>
       </p:sp>
       <p:sp>
         <p:nvSpPr>
@@ -16282,6 +16570,10 @@
           </a:solidFill>
           <a:ln/>
         </p:spPr>
+        <p:txBody>
+          <a:bodyPr/>
+          <a:p/>
+        </p:txBody>
       </p:sp>
       <p:sp>
         <p:nvSpPr>
@@ -16431,6 +16723,10 @@
             </a:outerShdw>
           </a:effectLst>
         </p:spPr>
+        <p:txBody>
+          <a:bodyPr/>
+          <a:p/>
+        </p:txBody>
       </p:sp>
       <p:sp>
         <p:nvSpPr>
@@ -16451,6 +16747,10 @@
           </a:solidFill>
           <a:ln/>
         </p:spPr>
+        <p:txBody>
+          <a:bodyPr/>
+          <a:p/>
+        </p:txBody>
       </p:sp>
       <p:sp>
         <p:nvSpPr>
@@ -16561,6 +16861,10 @@
             </a:outerShdw>
           </a:effectLst>
         </p:spPr>
+        <p:txBody>
+          <a:bodyPr/>
+          <a:p/>
+        </p:txBody>
       </p:sp>
       <p:sp>
         <p:nvSpPr>
@@ -16581,6 +16885,10 @@
           </a:solidFill>
           <a:ln/>
         </p:spPr>
+        <p:txBody>
+          <a:bodyPr/>
+          <a:p/>
+        </p:txBody>
       </p:sp>
       <p:sp>
         <p:nvSpPr>
@@ -16691,6 +16999,10 @@
             </a:outerShdw>
           </a:effectLst>
         </p:spPr>
+        <p:txBody>
+          <a:bodyPr/>
+          <a:p/>
+        </p:txBody>
       </p:sp>
       <p:sp>
         <p:nvSpPr>
@@ -16711,6 +17023,10 @@
           </a:solidFill>
           <a:ln/>
         </p:spPr>
+        <p:txBody>
+          <a:bodyPr/>
+          <a:p/>
+        </p:txBody>
       </p:sp>
       <p:sp>
         <p:nvSpPr>
@@ -16821,6 +17137,10 @@
             </a:outerShdw>
           </a:effectLst>
         </p:spPr>
+        <p:txBody>
+          <a:bodyPr/>
+          <a:p/>
+        </p:txBody>
       </p:sp>
       <p:sp>
         <p:nvSpPr>
@@ -16841,6 +17161,10 @@
           </a:solidFill>
           <a:ln/>
         </p:spPr>
+        <p:txBody>
+          <a:bodyPr/>
+          <a:p/>
+        </p:txBody>
       </p:sp>
       <p:sp>
         <p:nvSpPr>
@@ -16951,6 +17275,10 @@
             </a:outerShdw>
           </a:effectLst>
         </p:spPr>
+        <p:txBody>
+          <a:bodyPr/>
+          <a:p/>
+        </p:txBody>
       </p:sp>
       <p:sp>
         <p:nvSpPr>
@@ -16971,6 +17299,10 @@
           </a:solidFill>
           <a:ln/>
         </p:spPr>
+        <p:txBody>
+          <a:bodyPr/>
+          <a:p/>
+        </p:txBody>
       </p:sp>
       <p:sp>
         <p:nvSpPr>
@@ -17081,6 +17413,10 @@
             </a:outerShdw>
           </a:effectLst>
         </p:spPr>
+        <p:txBody>
+          <a:bodyPr/>
+          <a:p/>
+        </p:txBody>
       </p:sp>
       <p:sp>
         <p:nvSpPr>
@@ -17101,6 +17437,10 @@
           </a:solidFill>
           <a:ln/>
         </p:spPr>
+        <p:txBody>
+          <a:bodyPr/>
+          <a:p/>
+        </p:txBody>
       </p:sp>
       <p:sp>
         <p:nvSpPr>
@@ -17211,6 +17551,10 @@
             </a:outerShdw>
           </a:effectLst>
         </p:spPr>
+        <p:txBody>
+          <a:bodyPr/>
+          <a:p/>
+        </p:txBody>
       </p:sp>
       <p:sp>
         <p:nvSpPr>
@@ -17231,6 +17575,10 @@
           </a:solidFill>
           <a:ln/>
         </p:spPr>
+        <p:txBody>
+          <a:bodyPr/>
+          <a:p/>
+        </p:txBody>
       </p:sp>
       <p:sp>
         <p:nvSpPr>
@@ -17341,6 +17689,10 @@
             </a:outerShdw>
           </a:effectLst>
         </p:spPr>
+        <p:txBody>
+          <a:bodyPr/>
+          <a:p/>
+        </p:txBody>
       </p:sp>
       <p:sp>
         <p:nvSpPr>
@@ -17361,6 +17713,10 @@
           </a:solidFill>
           <a:ln/>
         </p:spPr>
+        <p:txBody>
+          <a:bodyPr/>
+          <a:p/>
+        </p:txBody>
       </p:sp>
       <p:sp>
         <p:nvSpPr>
@@ -17611,6 +17967,10 @@
           </a:solidFill>
           <a:ln/>
         </p:spPr>
+        <p:txBody>
+          <a:bodyPr/>
+          <a:p/>
+        </p:txBody>
       </p:sp>
       <p:pic>
         <p:nvPicPr>
@@ -17703,6 +18063,10 @@
             </a:outerShdw>
           </a:effectLst>
         </p:spPr>
+        <p:txBody>
+          <a:bodyPr/>
+          <a:p/>
+        </p:txBody>
       </p:sp>
       <p:sp>
         <p:nvSpPr>
@@ -17723,6 +18087,10 @@
           </a:solidFill>
           <a:ln/>
         </p:spPr>
+        <p:txBody>
+          <a:bodyPr/>
+          <a:p/>
+        </p:txBody>
       </p:sp>
       <p:sp>
         <p:nvSpPr>
@@ -17833,6 +18201,10 @@
             </a:outerShdw>
           </a:effectLst>
         </p:spPr>
+        <p:txBody>
+          <a:bodyPr/>
+          <a:p/>
+        </p:txBody>
       </p:sp>
       <p:sp>
         <p:nvSpPr>
@@ -17853,6 +18225,10 @@
           </a:solidFill>
           <a:ln/>
         </p:spPr>
+        <p:txBody>
+          <a:bodyPr/>
+          <a:p/>
+        </p:txBody>
       </p:sp>
       <p:sp>
         <p:nvSpPr>
@@ -17963,6 +18339,10 @@
             </a:outerShdw>
           </a:effectLst>
         </p:spPr>
+        <p:txBody>
+          <a:bodyPr/>
+          <a:p/>
+        </p:txBody>
       </p:sp>
       <p:sp>
         <p:nvSpPr>
@@ -17983,6 +18363,10 @@
           </a:solidFill>
           <a:ln/>
         </p:spPr>
+        <p:txBody>
+          <a:bodyPr/>
+          <a:p/>
+        </p:txBody>
       </p:sp>
       <p:sp>
         <p:nvSpPr>
@@ -18093,6 +18477,10 @@
             </a:outerShdw>
           </a:effectLst>
         </p:spPr>
+        <p:txBody>
+          <a:bodyPr/>
+          <a:p/>
+        </p:txBody>
       </p:sp>
       <p:sp>
         <p:nvSpPr>
@@ -18113,6 +18501,10 @@
           </a:solidFill>
           <a:ln/>
         </p:spPr>
+        <p:txBody>
+          <a:bodyPr/>
+          <a:p/>
+        </p:txBody>
       </p:sp>
       <p:sp>
         <p:nvSpPr>
@@ -18223,6 +18615,10 @@
             </a:outerShdw>
           </a:effectLst>
         </p:spPr>
+        <p:txBody>
+          <a:bodyPr/>
+          <a:p/>
+        </p:txBody>
       </p:sp>
       <p:sp>
         <p:nvSpPr>
@@ -18243,6 +18639,10 @@
           </a:solidFill>
           <a:ln/>
         </p:spPr>
+        <p:txBody>
+          <a:bodyPr/>
+          <a:p/>
+        </p:txBody>
       </p:sp>
       <p:sp>
         <p:nvSpPr>
@@ -18353,6 +18753,10 @@
             </a:outerShdw>
           </a:effectLst>
         </p:spPr>
+        <p:txBody>
+          <a:bodyPr/>
+          <a:p/>
+        </p:txBody>
       </p:sp>
       <p:sp>
         <p:nvSpPr>
@@ -18373,6 +18777,10 @@
           </a:solidFill>
           <a:ln/>
         </p:spPr>
+        <p:txBody>
+          <a:bodyPr/>
+          <a:p/>
+        </p:txBody>
       </p:sp>
       <p:sp>
         <p:nvSpPr>
@@ -18476,6 +18884,10 @@
           </a:solidFill>
           <a:ln/>
         </p:spPr>
+        <p:txBody>
+          <a:bodyPr/>
+          <a:p/>
+        </p:txBody>
       </p:sp>
       <p:sp>
         <p:nvSpPr>
@@ -18645,6 +19057,10 @@
           </a:solidFill>
           <a:ln/>
         </p:spPr>
+        <p:txBody>
+          <a:bodyPr/>
+          <a:p/>
+        </p:txBody>
       </p:sp>
       <p:pic>
         <p:nvPicPr>
@@ -18737,6 +19153,10 @@
             </a:outerShdw>
           </a:effectLst>
         </p:spPr>
+        <p:txBody>
+          <a:bodyPr/>
+          <a:p/>
+        </p:txBody>
       </p:sp>
       <p:sp>
         <p:nvSpPr>
@@ -18907,6 +19327,10 @@
           </a:solidFill>
           <a:ln/>
         </p:spPr>
+        <p:txBody>
+          <a:bodyPr/>
+          <a:p/>
+        </p:txBody>
       </p:sp>
       <p:sp>
         <p:nvSpPr>
@@ -19224,6 +19648,10 @@
           </a:solidFill>
           <a:ln/>
         </p:spPr>
+        <p:txBody>
+          <a:bodyPr/>
+          <a:p/>
+        </p:txBody>
       </p:sp>
       <p:pic>
         <p:nvPicPr>
@@ -19309,6 +19737,10 @@
           </a:solidFill>
           <a:ln/>
         </p:spPr>
+        <p:txBody>
+          <a:bodyPr/>
+          <a:p/>
+        </p:txBody>
       </p:sp>
       <p:sp>
         <p:nvSpPr>
@@ -19419,6 +19851,10 @@
             </a:outerShdw>
           </a:effectLst>
         </p:spPr>
+        <p:txBody>
+          <a:bodyPr/>
+          <a:p/>
+        </p:txBody>
       </p:sp>
       <p:sp>
         <p:nvSpPr>
@@ -19439,6 +19875,10 @@
           </a:solidFill>
           <a:ln/>
         </p:spPr>
+        <p:txBody>
+          <a:bodyPr/>
+          <a:p/>
+        </p:txBody>
       </p:sp>
       <p:pic>
         <p:nvPicPr>
@@ -19534,6 +19974,10 @@
             </a:outerShdw>
           </a:effectLst>
         </p:spPr>
+        <p:txBody>
+          <a:bodyPr/>
+          <a:p/>
+        </p:txBody>
       </p:sp>
       <p:sp>
         <p:nvSpPr>
@@ -19554,6 +19998,10 @@
           </a:solidFill>
           <a:ln/>
         </p:spPr>
+        <p:txBody>
+          <a:bodyPr/>
+          <a:p/>
+        </p:txBody>
       </p:sp>
       <p:pic>
         <p:nvPicPr>
@@ -19649,6 +20097,10 @@
             </a:outerShdw>
           </a:effectLst>
         </p:spPr>
+        <p:txBody>
+          <a:bodyPr/>
+          <a:p/>
+        </p:txBody>
       </p:sp>
       <p:sp>
         <p:nvSpPr>
@@ -19669,6 +20121,10 @@
           </a:solidFill>
           <a:ln/>
         </p:spPr>
+        <p:txBody>
+          <a:bodyPr/>
+          <a:p/>
+        </p:txBody>
       </p:sp>
       <p:pic>
         <p:nvPicPr>
@@ -19904,6 +20360,10 @@
           </a:solidFill>
           <a:ln/>
         </p:spPr>
+        <p:txBody>
+          <a:bodyPr/>
+          <a:p/>
+        </p:txBody>
       </p:sp>
       <p:pic>
         <p:nvPicPr>
@@ -19996,6 +20456,10 @@
             </a:outerShdw>
           </a:effectLst>
         </p:spPr>
+        <p:txBody>
+          <a:bodyPr/>
+          <a:p/>
+        </p:txBody>
       </p:sp>
       <p:sp>
         <p:nvSpPr>
@@ -20016,6 +20480,10 @@
           </a:solidFill>
           <a:ln/>
         </p:spPr>
+        <p:txBody>
+          <a:bodyPr/>
+          <a:p/>
+        </p:txBody>
       </p:sp>
       <p:sp>
         <p:nvSpPr>
@@ -20075,6 +20543,10 @@
           </a:solidFill>
           <a:ln/>
         </p:spPr>
+        <p:txBody>
+          <a:bodyPr/>
+          <a:p/>
+        </p:txBody>
       </p:sp>
       <p:pic>
         <p:nvPicPr>
@@ -20212,6 +20684,10 @@
             </a:outerShdw>
           </a:effectLst>
         </p:spPr>
+        <p:txBody>
+          <a:bodyPr/>
+          <a:p/>
+        </p:txBody>
       </p:sp>
       <p:sp>
         <p:nvSpPr>
@@ -20232,6 +20708,10 @@
           </a:solidFill>
           <a:ln/>
         </p:spPr>
+        <p:txBody>
+          <a:bodyPr/>
+          <a:p/>
+        </p:txBody>
       </p:sp>
       <p:sp>
         <p:nvSpPr>
@@ -20291,6 +20771,10 @@
           </a:solidFill>
           <a:ln/>
         </p:spPr>
+        <p:txBody>
+          <a:bodyPr/>
+          <a:p/>
+        </p:txBody>
       </p:sp>
       <p:pic>
         <p:nvPicPr>
@@ -20428,6 +20912,10 @@
             </a:outerShdw>
           </a:effectLst>
         </p:spPr>
+        <p:txBody>
+          <a:bodyPr/>
+          <a:p/>
+        </p:txBody>
       </p:sp>
       <p:sp>
         <p:nvSpPr>
@@ -20448,6 +20936,10 @@
           </a:solidFill>
           <a:ln/>
         </p:spPr>
+        <p:txBody>
+          <a:bodyPr/>
+          <a:p/>
+        </p:txBody>
       </p:sp>
       <p:sp>
         <p:nvSpPr>
@@ -20507,6 +20999,10 @@
           </a:solidFill>
           <a:ln/>
         </p:spPr>
+        <p:txBody>
+          <a:bodyPr/>
+          <a:p/>
+        </p:txBody>
       </p:sp>
       <p:pic>
         <p:nvPicPr>
@@ -20644,6 +21140,10 @@
             </a:outerShdw>
           </a:effectLst>
         </p:spPr>
+        <p:txBody>
+          <a:bodyPr/>
+          <a:p/>
+        </p:txBody>
       </p:sp>
       <p:sp>
         <p:nvSpPr>
@@ -20664,6 +21164,10 @@
           </a:solidFill>
           <a:ln/>
         </p:spPr>
+        <p:txBody>
+          <a:bodyPr/>
+          <a:p/>
+        </p:txBody>
       </p:sp>
       <p:sp>
         <p:nvSpPr>
@@ -20723,6 +21227,10 @@
           </a:solidFill>
           <a:ln/>
         </p:spPr>
+        <p:txBody>
+          <a:bodyPr/>
+          <a:p/>
+        </p:txBody>
       </p:sp>
       <p:pic>
         <p:nvPicPr>
@@ -21000,6 +21508,10 @@
           </a:solidFill>
           <a:ln/>
         </p:spPr>
+        <p:txBody>
+          <a:bodyPr/>
+          <a:p/>
+        </p:txBody>
       </p:sp>
       <p:pic>
         <p:nvPicPr>
@@ -21092,6 +21604,10 @@
             </a:outerShdw>
           </a:effectLst>
         </p:spPr>
+        <p:txBody>
+          <a:bodyPr/>
+          <a:p/>
+        </p:txBody>
       </p:sp>
       <p:sp>
         <p:nvSpPr>
@@ -21112,6 +21628,10 @@
           </a:solidFill>
           <a:ln/>
         </p:spPr>
+        <p:txBody>
+          <a:bodyPr/>
+          <a:p/>
+        </p:txBody>
       </p:sp>
       <p:pic>
         <p:nvPicPr>
@@ -21267,6 +21787,10 @@
           </a:solidFill>
           <a:ln/>
         </p:spPr>
+        <p:txBody>
+          <a:bodyPr/>
+          <a:p/>
+        </p:txBody>
       </p:sp>
       <p:sp>
         <p:nvSpPr>
@@ -21287,6 +21811,10 @@
           </a:solidFill>
           <a:ln/>
         </p:spPr>
+        <p:txBody>
+          <a:bodyPr/>
+          <a:p/>
+        </p:txBody>
       </p:sp>
       <p:pic>
         <p:nvPicPr>
@@ -21449,6 +21977,10 @@
             </a:outerShdw>
           </a:effectLst>
         </p:spPr>
+        <p:txBody>
+          <a:bodyPr/>
+          <a:p/>
+        </p:txBody>
       </p:sp>
       <p:sp>
         <p:nvSpPr>
@@ -21618,6 +22150,10 @@
           </a:solidFill>
           <a:ln/>
         </p:spPr>
+        <p:txBody>
+          <a:bodyPr/>
+          <a:p/>
+        </p:txBody>
       </p:sp>
       <p:pic>
         <p:nvPicPr>
@@ -21710,6 +22246,10 @@
             </a:outerShdw>
           </a:effectLst>
         </p:spPr>
+        <p:txBody>
+          <a:bodyPr/>
+          <a:p/>
+        </p:txBody>
       </p:sp>
       <p:sp>
         <p:nvSpPr>
@@ -21769,6 +22309,10 @@
           </a:solidFill>
           <a:ln/>
         </p:spPr>
+        <p:txBody>
+          <a:bodyPr/>
+          <a:p/>
+        </p:txBody>
       </p:sp>
       <p:sp>
         <p:nvSpPr>
@@ -21867,6 +22411,10 @@
           </a:solidFill>
           <a:ln/>
         </p:spPr>
+        <p:txBody>
+          <a:bodyPr/>
+          <a:p/>
+        </p:txBody>
       </p:sp>
       <p:sp>
         <p:nvSpPr>
@@ -21965,6 +22513,10 @@
           </a:solidFill>
           <a:ln/>
         </p:spPr>
+        <p:txBody>
+          <a:bodyPr/>
+          <a:p/>
+        </p:txBody>
       </p:sp>
       <p:sp>
         <p:nvSpPr>
@@ -22065,6 +22617,10 @@
           </a:solidFill>
           <a:ln/>
         </p:spPr>
+        <p:txBody>
+          <a:bodyPr/>
+          <a:p/>
+        </p:txBody>
       </p:sp>
       <p:sp>
         <p:nvSpPr>

</xml_diff>